<commit_message>
docs(outputs): regenerate the setting-guide PPTX with current tool names
   The committed file was built 2026-07-01, before the sangfor.* -> sangfor_* rename,
   so slide 12 still showed sangfor.start_operator_session and
   sangfor.dry_run_product_change. The generator source was already correct.
</commit_message>
<xml_diff>
--- a/outputs/Sangfor_설정가이드_MCP.pptx
+++ b/outputs/Sangfor_설정가이드_MCP.pptx
@@ -2495,7 +2495,7 @@
                 <a:ea typeface="Calibri" pitchFamily="34" charset="-122"/>
                 <a:cs typeface="Calibri" pitchFamily="34" charset="-120"/>
               </a:rPr>
-              <a:t>생성일: 2026-07-01</a:t>
+              <a:t>생성일: 2026-08-12</a:t>
             </a:r>
             <a:endParaRPr lang="en-US" sz="1100" dirty="0"/>
           </a:p>
@@ -4438,7 +4438,7 @@
                 <a:ea typeface="Calibri" pitchFamily="34" charset="-122"/>
                 <a:cs typeface="Calibri" pitchFamily="34" charset="-120"/>
               </a:rPr>
-              <a:t>MCP의 sangfor.start_operator_session 도구로 제품, targetUrl, CDP endpoint를 지정한다.</a:t>
+              <a:t>MCP의 sangfor_start_operator_session 도구로 제품, targetUrl, CDP endpoint를 지정한다.</a:t>
             </a:r>
             <a:endParaRPr lang="en-US" sz="1000" dirty="0"/>
           </a:p>
@@ -4577,7 +4577,7 @@
                 <a:ea typeface="Calibri" pitchFamily="34" charset="-122"/>
                 <a:cs typeface="Calibri" pitchFamily="34" charset="-120"/>
               </a:rPr>
-              <a:t>sangfor.dry_run_product_change에 생성된 계획서와 sessionId를 전달한다.</a:t>
+              <a:t>sangfor_dry_run_product_change에 생성된 계획서와 sessionId를 전달한다.</a:t>
             </a:r>
             <a:endParaRPr lang="en-US" sz="1000" dirty="0"/>
           </a:p>

</xml_diff>